<commit_message>
Update presentation with prose format instead of bullet points
Recreated PowerPoint slides with full conversational prose text
matching the speech notes structure. Each slide displays the
actual speaking content in readable paragraph format rather than
summarized bullet points.

5 slides total (468 words):
- Slide 1: Title and introduction
- Slide 2: Core Claims (3 claims in prose)
- Slide 3: Research Methodology (3 frameworks)
- Slide 4: Key Findings
- Slide 5: Lessons Learned and Future Direction
</commit_message>
<xml_diff>
--- a/Qatar_Legal_Chokepoint_Presentation.pptx
+++ b/Qatar_Legal_Chokepoint_Presentation.pptx
@@ -3100,8 +3100,8 @@
         </p:nvSpPr>
         <p:spPr>
           <a:xfrm>
-            <a:off x="457200" y="1828800"/>
-            <a:ext cx="8229600" cy="1828800"/>
+            <a:off x="914400" y="2286000"/>
+            <a:ext cx="7315200" cy="1371600"/>
           </a:xfrm>
           <a:prstGeom prst="rect">
             <a:avLst/>
@@ -3115,7 +3115,7 @@
           <a:lstStyle/>
           <a:p>
             <a:pPr algn="ctr">
-              <a:defRPr sz="3600" b="1"/>
+              <a:defRPr sz="3200" b="1"/>
             </a:pPr>
             <a:r>
               <a:t>Qatar as a Legal Chokepoint:</a:t>
@@ -3136,8 +3136,8 @@
         </p:nvSpPr>
         <p:spPr>
           <a:xfrm>
-            <a:off x="457200" y="4114800"/>
-            <a:ext cx="8229600" cy="1371600"/>
+            <a:off x="914400" y="4114800"/>
+            <a:ext cx="7315200" cy="1828800"/>
           </a:xfrm>
           <a:prstGeom prst="rect">
             <a:avLst/>
@@ -3145,21 +3145,16 @@
           <a:noFill/>
         </p:spPr>
         <p:txBody>
-          <a:bodyPr wrap="none">
+          <a:bodyPr wrap="square">
             <a:spAutoFit/>
           </a:bodyPr>
           <a:lstStyle/>
           <a:p>
             <a:pPr algn="ctr">
-              <a:defRPr sz="2000"/>
+              <a:defRPr sz="1800"/>
             </a:pPr>
             <a:r>
-              <a:t>LL.M Thesis Presentation</a:t>
-            </a:r>
-          </a:p>
-          <a:p>
-            <a:r>
-              <a:t>Research Methods in Law</a:t>
+              <a:t>Good afternoon. My thesis investigates Qatar as a legal chokepoint, examining how economic warfare exposes critical gaps in international law when dominant powers weaponise interdependence at strategic infrastructure nodes.</a:t>
             </a:r>
           </a:p>
         </p:txBody>
@@ -3205,7 +3200,7 @@
           <a:lstStyle/>
           <a:p>
             <a:pPr>
-              <a:defRPr sz="2800" b="1"/>
+              <a:defRPr sz="3200" b="1"/>
             </a:pPr>
             <a:r>
               <a:t>Core Claims</a:t>
@@ -3221,8 +3216,8 @@
         </p:nvSpPr>
         <p:spPr>
           <a:xfrm>
-            <a:off x="457200" y="1097280"/>
-            <a:ext cx="8229600" cy="5029200"/>
+            <a:off x="457200" y="1005840"/>
+            <a:ext cx="8229600" cy="5486400"/>
           </a:xfrm>
           <a:prstGeom prst="rect">
             <a:avLst/>
@@ -3237,64 +3232,31 @@
           <a:p>
             <a:pPr>
               <a:spcAft>
-                <a:spcPts val="800"/>
+                <a:spcPts val="1400"/>
               </a:spcAft>
-              <a:defRPr sz="1600" b="1"/>
+              <a:defRPr sz="1600"/>
             </a:pPr>
             <a:r>
-              <a:t>Claim 1: Transnational Legal Exposure</a:t>
-            </a:r>
-          </a:p>
-          <a:p>
-            <a:pPr lvl="1">
-              <a:spcAft>
-                <a:spcPts val="1200"/>
-              </a:spcAft>
-              <a:defRPr sz="1400"/>
-            </a:pPr>
-            <a:r>
-              <a:t>Qatar shares control of the world's largest gas reserve with Iran, creating unique legal exposure under extraterritorial sanctions (OFAC). These sanctions override territorial sovereignty, reducing Qatar's control from substantive to nominal.</a:t>
+              <a:t>My research advances three interconnected claims. First, Qatar faces unique transnational legal exposure because it shares the world's largest natural gas reserve with Iran. US sanctions imposed by the Office of Foreign Assets Control operate extraterritorially, overriding Qatar's territorial sovereignty. Even without Qatar's consent, OFAC sets the regulatory boundaries within which Qatar exploits its hydrocarbon resources, reducing sovereignty from substantive to nominal control.</a:t>
             </a:r>
           </a:p>
           <a:p>
             <a:pPr>
               <a:spcAft>
-                <a:spcPts val="800"/>
+                <a:spcPts val="1400"/>
               </a:spcAft>
-              <a:defRPr sz="1600" b="1"/>
+              <a:defRPr sz="1600"/>
             </a:pPr>
             <a:r>
-              <a:t>Claim 2: Contradiction to State Sovereignty</a:t>
-            </a:r>
-          </a:p>
-          <a:p>
-            <a:pPr lvl="1">
-              <a:spcAft>
-                <a:spcPts val="1200"/>
-              </a:spcAft>
-              <a:defRPr sz="1400"/>
+              <a:t>Second, I argue this strategic coercion through economic interdependence fundamentally contradicts the dominant legal doctrine of state sovereignty within international law. The weaponisation of interdependence through secondary sanctions and extraterritorial regimes erodes Qatar's sovereign authority, breaching protections under UNCLOS Articles 56 and 77, as well as Qatar's Law No. 8 of 2004 concerning exclusive sovereign rights over maritime resources.</a:t>
+            </a:r>
+          </a:p>
+          <a:p>
+            <a:pPr>
+              <a:defRPr sz="1600"/>
             </a:pPr>
             <a:r>
-              <a:t>Economic interdependence at critical chokepoints fundamentally contradicts dominant legal doctrine of state sovereignty. Weaponised interdependence violates UNCLOS Articles 56, 77 and Qatar's Law No. (8) of 2004.</a:t>
-            </a:r>
-          </a:p>
-          <a:p>
-            <a:pPr>
-              <a:spcAft>
-                <a:spcPts val="800"/>
-              </a:spcAft>
-              <a:defRPr sz="1600" b="1"/>
-            </a:pPr>
-            <a:r>
-              <a:t>Claim 3: Multi-Forum Legal Strategy Reveals Gaps</a:t>
-            </a:r>
-          </a:p>
-          <a:p>
-            <a:pPr lvl="1">
-              <a:defRPr sz="1400"/>
-            </a:pPr>
-            <a:r>
-              <a:t>Qatar's simultaneous litigation (ICJ, ICAO, CERD) during 2017-2021 blockade revealed major gaps in protecting chokepoint states from economic warfare.</a:t>
+              <a:t>Third, Qatar's multi-forum legal strategy during the 2017-2021 blockade—bringing cases simultaneously to the ICJ, ICAO Council, and CERD Committee—revealed that current legal systems provide little protection against economic pressure on chokepoint states, potentially encouraging future blockades.</a:t>
             </a:r>
           </a:p>
         </p:txBody>
@@ -3340,7 +3302,7 @@
           <a:lstStyle/>
           <a:p>
             <a:pPr>
-              <a:defRPr sz="2800" b="1"/>
+              <a:defRPr sz="3200" b="1"/>
             </a:pPr>
             <a:r>
               <a:t>Research Methodology</a:t>
@@ -3356,8 +3318,8 @@
         </p:nvSpPr>
         <p:spPr>
           <a:xfrm>
-            <a:off x="457200" y="1097280"/>
-            <a:ext cx="8229600" cy="5029200"/>
+            <a:off x="457200" y="1005840"/>
+            <a:ext cx="8229600" cy="5486400"/>
           </a:xfrm>
           <a:prstGeom prst="rect">
             <a:avLst/>
@@ -3372,64 +3334,20 @@
           <a:p>
             <a:pPr>
               <a:spcAft>
-                <a:spcPts val="800"/>
+                <a:spcPts val="1400"/>
               </a:spcAft>
-              <a:defRPr sz="1600" b="1"/>
+              <a:defRPr sz="1600"/>
             </a:pPr>
             <a:r>
-              <a:t>1. Doctrinal Legal Analysis</a:t>
-            </a:r>
-          </a:p>
-          <a:p>
-            <a:pPr lvl="1">
-              <a:spcAft>
-                <a:spcPts val="1200"/>
-              </a:spcAft>
-              <a:defRPr sz="1400"/>
+              <a:t>I employ three methodological frameworks. Doctrinal legal analysis examines sovereignty principles, jurisdictional doctrines, and treaty obligations, revealing that remedies remain procedural rather than substantive. Comparative case studies of Qatar, Russia, Iran, and Taiwan demonstrate that international law distinguishes by legal form—blockade, sanctions, export controls—rather than economic effect. While territorial blockades trigger aviation frameworks, functional blockades via insurance denial or technology export controls have no legal remedy despite identical coercive impact.</a:t>
+            </a:r>
+          </a:p>
+          <a:p>
+            <a:pPr>
+              <a:defRPr sz="1600"/>
             </a:pPr>
             <a:r>
-              <a:t>Examines sovereignty, jurisdiction, and treaty obligations (UNCLOS, Chicago Convention). Reveals critical gap: remedies remain procedural rather than substantive.</a:t>
-            </a:r>
-          </a:p>
-          <a:p>
-            <a:pPr>
-              <a:spcAft>
-                <a:spcPts val="800"/>
-              </a:spcAft>
-              <a:defRPr sz="1600" b="1"/>
-            </a:pPr>
-            <a:r>
-              <a:t>2. Comparative Case Study</a:t>
-            </a:r>
-          </a:p>
-          <a:p>
-            <a:pPr lvl="1">
-              <a:spcAft>
-                <a:spcPts val="1200"/>
-              </a:spcAft>
-              <a:defRPr sz="1400"/>
-            </a:pPr>
-            <a:r>
-              <a:t>Compares Qatar (2017-2021), Russia (2022-present), Iran (2011-2025), Taiwan (2022-present). Demonstrates international law distinguishes by legal form rather than economic effect—territorial blockades trigger aviation law, but functional blockades lack legal remedy.</a:t>
-            </a:r>
-          </a:p>
-          <a:p>
-            <a:pPr>
-              <a:spcAft>
-                <a:spcPts val="800"/>
-              </a:spcAft>
-              <a:defRPr sz="1600" b="1"/>
-            </a:pPr>
-            <a:r>
-              <a:t>3. Interdisciplinary Integration (McCrudden Framework)</a:t>
-            </a:r>
-          </a:p>
-          <a:p>
-            <a:pPr lvl="1">
-              <a:defRPr sz="1400"/>
-            </a:pPr>
-            <a:r>
-              <a:t>Applies 'two-way traffic' between law and social sciences to understand why economic power overrides legal validity. Example: Russian oil price cap works through market control (95% insurance concentration), not legal authority.</a:t>
+              <a:t>Following McCrudden's interdisciplinary framework, I integrate economic analysis to understand why economic power overrides legal validity. The Russian oil price cap illustrates this perfectly: it works through market control—the West controls 95% of maritime insurance—not through clear legal authority.</a:t>
             </a:r>
           </a:p>
         </p:txBody>
@@ -3475,10 +3393,10 @@
           <a:lstStyle/>
           <a:p>
             <a:pPr>
-              <a:defRPr sz="2800" b="1"/>
+              <a:defRPr sz="3200" b="1"/>
             </a:pPr>
             <a:r>
-              <a:t>Key Findings &amp; Legal Gaps</a:t>
+              <a:t>Key Findings</a:t>
             </a:r>
           </a:p>
         </p:txBody>
@@ -3491,8 +3409,8 @@
         </p:nvSpPr>
         <p:spPr>
           <a:xfrm>
-            <a:off x="457200" y="1097280"/>
-            <a:ext cx="8229600" cy="5029200"/>
+            <a:off x="457200" y="1005840"/>
+            <a:ext cx="8229600" cy="5486400"/>
           </a:xfrm>
           <a:prstGeom prst="rect">
             <a:avLst/>
@@ -3507,64 +3425,20 @@
           <a:p>
             <a:pPr>
               <a:spcAft>
-                <a:spcPts val="800"/>
+                <a:spcPts val="1400"/>
               </a:spcAft>
-              <a:defRPr sz="1600" b="1"/>
+              <a:defRPr sz="1600"/>
             </a:pPr>
             <a:r>
-              <a:t>ICJ Jurisdictional Victory Without Substantive Protection</a:t>
-            </a:r>
-          </a:p>
-          <a:p>
-            <a:pPr lvl="1">
-              <a:spcAft>
-                <a:spcPts val="1200"/>
-              </a:spcAft>
-              <a:defRPr sz="1400"/>
+              <a:t>The ICJ affirmed jurisdiction over Qatar's case in 2020, but the matter settled in 2021 without merits determination or compensation. This reveals that international law provides formal remedies but no practical protection—it is reactive, not preventative.</a:t>
+            </a:r>
+          </a:p>
+          <a:p>
+            <a:pPr>
+              <a:defRPr sz="1600"/>
             </a:pPr>
             <a:r>
-              <a:t>ICJ affirmed ICAO jurisdiction (2020), but case settled without merits determination or compensation (2021). International law provides formal remedy but no practical protection—reactive, not preventative.</a:t>
-            </a:r>
-          </a:p>
-          <a:p>
-            <a:pPr>
-              <a:spcAft>
-                <a:spcPts val="800"/>
-              </a:spcAft>
-              <a:defRPr sz="1600" b="1"/>
-            </a:pPr>
-            <a:r>
-              <a:t>Form vs. Effect Problem</a:t>
-            </a:r>
-          </a:p>
-          <a:p>
-            <a:pPr lvl="1">
-              <a:spcAft>
-                <a:spcPts val="1200"/>
-              </a:spcAft>
-              <a:defRPr sz="1400"/>
-            </a:pPr>
-            <a:r>
-              <a:t>Current law distinguishes by legal form (blockade/sanctions/export controls) rather than economic effect. Territorial blockade triggers ICAO; insurance blockade and tech export controls with identical coercive impact have no forum. International law fails to recognize functional equivalence.</a:t>
-            </a:r>
-          </a:p>
-          <a:p>
-            <a:pPr>
-              <a:spcAft>
-                <a:spcPts val="800"/>
-              </a:spcAft>
-              <a:defRPr sz="1600" b="1"/>
-            </a:pPr>
-            <a:r>
-              <a:t>Weaponised Interdependence &amp; Erosion of Sovereignty</a:t>
-            </a:r>
-          </a:p>
-          <a:p>
-            <a:pPr lvl="1">
-              <a:defRPr sz="1400"/>
-            </a:pPr>
-            <a:r>
-              <a:t>Extraterritorial sanctions (OFAC) create artificial legal boundaries that override sovereign equality. Fishman's 'invisible infrastructure' (dollar clearing, SWIFT, maritime insurance) enables economic warfare without military force, revealing sovereignty is nominal when compliance infrastructures privatize enforcement.</a:t>
+              <a:t>Current law fails to recognize functional equivalence. Fishman's concept of "invisible infrastructure"—dollar clearing systems, SWIFT networks, maritime insurance—enables economic warfare without military force, showing how compliance infrastructures have privatised enforcement of state policy.</a:t>
             </a:r>
           </a:p>
         </p:txBody>
@@ -3613,7 +3487,7 @@
               <a:defRPr sz="2800" b="1"/>
             </a:pPr>
             <a:r>
-              <a:t>Lessons Learned &amp; Feedback Implementation</a:t>
+              <a:t>Lessons Learned and Future Direction</a:t>
             </a:r>
           </a:p>
         </p:txBody>
@@ -3626,8 +3500,8 @@
         </p:nvSpPr>
         <p:spPr>
           <a:xfrm>
-            <a:off x="457200" y="1097280"/>
-            <a:ext cx="8229600" cy="5029200"/>
+            <a:off x="457200" y="1005840"/>
+            <a:ext cx="8229600" cy="5486400"/>
           </a:xfrm>
           <a:prstGeom prst="rect">
             <a:avLst/>
@@ -3642,88 +3516,20 @@
           <a:p>
             <a:pPr>
               <a:spcAft>
-                <a:spcPts val="800"/>
+                <a:spcPts val="1400"/>
               </a:spcAft>
-              <a:defRPr sz="1600" b="1"/>
+              <a:defRPr sz="1600"/>
             </a:pPr>
             <a:r>
-              <a:t>Key Feedback Integrated</a:t>
-            </a:r>
-          </a:p>
-          <a:p>
-            <a:pPr lvl="1">
-              <a:defRPr sz="1400"/>
+              <a:t>Incorporating feedback from previous sessions significantly strengthened this work. I enhanced specificity throughout my analysis, reorganized research questions from broad to specific, corrected citation formatting, and most critically, strengthened my methodological justification. I clarified why doctrinal analysis alone cannot explain how economic power overcomes legal validity, necessitating comparative and interdisciplinary approaches.</a:t>
+            </a:r>
+          </a:p>
+          <a:p>
+            <a:pPr>
+              <a:defRPr sz="1600"/>
             </a:pPr>
             <a:r>
-              <a:t>• Enhanced specificity throughout analysis (FA1, FA8)</a:t>
-            </a:r>
-          </a:p>
-          <a:p>
-            <a:pPr lvl="1">
-              <a:defRPr sz="1400"/>
-            </a:pPr>
-            <a:r>
-              <a:t>• Reorganized research questions from broad to specific (FA6)</a:t>
-            </a:r>
-          </a:p>
-          <a:p>
-            <a:pPr lvl="1">
-              <a:defRPr sz="1400"/>
-            </a:pPr>
-            <a:r>
-              <a:t>• Corrected grammar and terminology (FA7, FA14-FA16)</a:t>
-            </a:r>
-          </a:p>
-          <a:p>
-            <a:pPr lvl="1">
-              <a:spcAft>
-                <a:spcPts val="1200"/>
-              </a:spcAft>
-              <a:defRPr sz="1400"/>
-            </a:pPr>
-            <a:r>
-              <a:t>• Fixed citation formatting—single footnote per sentence (FA17)</a:t>
-            </a:r>
-          </a:p>
-          <a:p>
-            <a:pPr>
-              <a:spcAft>
-                <a:spcPts val="800"/>
-              </a:spcAft>
-              <a:defRPr sz="1600" b="1"/>
-            </a:pPr>
-            <a:r>
-              <a:t>Critical Methodological Refinement (FA22-FA25)</a:t>
-            </a:r>
-          </a:p>
-          <a:p>
-            <a:pPr lvl="1">
-              <a:spcAft>
-                <a:spcPts val="1200"/>
-              </a:spcAft>
-              <a:defRPr sz="1400"/>
-            </a:pPr>
-            <a:r>
-              <a:t>Strengthened justification for why doctrinal method connects to claims and research questions. Explained relationship between method and weaponised interdependence—doctrinal analysis alone cannot explain why economic power overcomes legal validity, requiring comparative and interdisciplinary approaches.</a:t>
-            </a:r>
-          </a:p>
-          <a:p>
-            <a:pPr>
-              <a:spcAft>
-                <a:spcPts val="800"/>
-              </a:spcAft>
-              <a:defRPr sz="1600" b="1"/>
-            </a:pPr>
-            <a:r>
-              <a:t>Future Direction: Effect-Based Taxonomy</a:t>
-            </a:r>
-          </a:p>
-          <a:p>
-            <a:pPr lvl="1">
-              <a:defRPr sz="1400"/>
-            </a:pPr>
-            <a:r>
-              <a:t>Develop empirical thresholds (e.g., 80% insurance market control, 2000 nautical mile rerouting) that translate into justiciable doctrine for courts to apply when chokepoint states allege functional strangulation.</a:t>
+              <a:t>My research proposes developing an effect-based taxonomy with empirical thresholds—such as insurance market concentration levels or shipping route extension distances—that courts can apply when chokepoint states allege functional strangulation. This addresses the fundamental gap: international law currently lacks categories adequate to weaponised interdependence at critical infrastructure nodes. Thank you.</a:t>
             </a:r>
           </a:p>
         </p:txBody>

</xml_diff>